<commit_message>
Added the title image and update the document.
</commit_message>
<xml_diff>
--- a/3_Articles_Doc/1_Fast_Setup_IT_System/img/DesignDoc.pptx
+++ b/3_Articles_Doc/1_Fast_Setup_IT_System/img/DesignDoc.pptx
@@ -5,12 +5,13 @@
     <p:sldMasterId id="2147483648" r:id="rId1"/>
   </p:sldMasterIdLst>
   <p:notesMasterIdLst>
-    <p:notesMasterId r:id="rId5"/>
+    <p:notesMasterId r:id="rId6"/>
   </p:notesMasterIdLst>
   <p:sldIdLst>
     <p:sldId id="256" r:id="rId2"/>
     <p:sldId id="257" r:id="rId3"/>
     <p:sldId id="258" r:id="rId4"/>
+    <p:sldId id="259" r:id="rId5"/>
   </p:sldIdLst>
   <p:sldSz cx="12192000" cy="6858000"/>
   <p:notesSz cx="6858000" cy="9144000"/>
@@ -109,6 +110,11 @@
       </a:defRPr>
     </a:lvl9pPr>
   </p:defaultTextStyle>
+  <p:extLst>
+    <p:ext uri="{EFAFB233-063F-42B5-8137-9DF3F51BA10A}">
+      <p15:sldGuideLst xmlns:p15="http://schemas.microsoft.com/office/powerpoint/2012/main"/>
+    </p:ext>
+  </p:extLst>
 </p:presentation>
 </file>
 
@@ -194,7 +200,7 @@
           <a:p>
             <a:fld id="{949FDE82-C59E-4D79-ABA0-A34ED563CE3E}" type="datetimeFigureOut">
               <a:rPr lang="en-SG" smtClean="0"/>
-              <a:t>19/3/2026</a:t>
+              <a:t>22/3/2026</a:t>
             </a:fld>
             <a:endParaRPr lang="en-SG"/>
           </a:p>
@@ -695,7 +701,7 @@
           <a:p>
             <a:fld id="{48E88D6B-047D-48A7-91CC-F0B0060D7484}" type="datetimeFigureOut">
               <a:rPr lang="en-SG" smtClean="0"/>
-              <a:t>19/3/2026</a:t>
+              <a:t>22/3/2026</a:t>
             </a:fld>
             <a:endParaRPr lang="en-SG"/>
           </a:p>
@@ -895,7 +901,7 @@
           <a:p>
             <a:fld id="{48E88D6B-047D-48A7-91CC-F0B0060D7484}" type="datetimeFigureOut">
               <a:rPr lang="en-SG" smtClean="0"/>
-              <a:t>19/3/2026</a:t>
+              <a:t>22/3/2026</a:t>
             </a:fld>
             <a:endParaRPr lang="en-SG"/>
           </a:p>
@@ -1105,7 +1111,7 @@
           <a:p>
             <a:fld id="{48E88D6B-047D-48A7-91CC-F0B0060D7484}" type="datetimeFigureOut">
               <a:rPr lang="en-SG" smtClean="0"/>
-              <a:t>19/3/2026</a:t>
+              <a:t>22/3/2026</a:t>
             </a:fld>
             <a:endParaRPr lang="en-SG"/>
           </a:p>
@@ -1305,7 +1311,7 @@
           <a:p>
             <a:fld id="{48E88D6B-047D-48A7-91CC-F0B0060D7484}" type="datetimeFigureOut">
               <a:rPr lang="en-SG" smtClean="0"/>
-              <a:t>19/3/2026</a:t>
+              <a:t>22/3/2026</a:t>
             </a:fld>
             <a:endParaRPr lang="en-SG"/>
           </a:p>
@@ -1581,7 +1587,7 @@
           <a:p>
             <a:fld id="{48E88D6B-047D-48A7-91CC-F0B0060D7484}" type="datetimeFigureOut">
               <a:rPr lang="en-SG" smtClean="0"/>
-              <a:t>19/3/2026</a:t>
+              <a:t>22/3/2026</a:t>
             </a:fld>
             <a:endParaRPr lang="en-SG"/>
           </a:p>
@@ -1849,7 +1855,7 @@
           <a:p>
             <a:fld id="{48E88D6B-047D-48A7-91CC-F0B0060D7484}" type="datetimeFigureOut">
               <a:rPr lang="en-SG" smtClean="0"/>
-              <a:t>19/3/2026</a:t>
+              <a:t>22/3/2026</a:t>
             </a:fld>
             <a:endParaRPr lang="en-SG"/>
           </a:p>
@@ -2264,7 +2270,7 @@
           <a:p>
             <a:fld id="{48E88D6B-047D-48A7-91CC-F0B0060D7484}" type="datetimeFigureOut">
               <a:rPr lang="en-SG" smtClean="0"/>
-              <a:t>19/3/2026</a:t>
+              <a:t>22/3/2026</a:t>
             </a:fld>
             <a:endParaRPr lang="en-SG"/>
           </a:p>
@@ -2406,7 +2412,7 @@
           <a:p>
             <a:fld id="{48E88D6B-047D-48A7-91CC-F0B0060D7484}" type="datetimeFigureOut">
               <a:rPr lang="en-SG" smtClean="0"/>
-              <a:t>19/3/2026</a:t>
+              <a:t>22/3/2026</a:t>
             </a:fld>
             <a:endParaRPr lang="en-SG"/>
           </a:p>
@@ -2519,7 +2525,7 @@
           <a:p>
             <a:fld id="{48E88D6B-047D-48A7-91CC-F0B0060D7484}" type="datetimeFigureOut">
               <a:rPr lang="en-SG" smtClean="0"/>
-              <a:t>19/3/2026</a:t>
+              <a:t>22/3/2026</a:t>
             </a:fld>
             <a:endParaRPr lang="en-SG"/>
           </a:p>
@@ -2832,7 +2838,7 @@
           <a:p>
             <a:fld id="{48E88D6B-047D-48A7-91CC-F0B0060D7484}" type="datetimeFigureOut">
               <a:rPr lang="en-SG" smtClean="0"/>
-              <a:t>19/3/2026</a:t>
+              <a:t>22/3/2026</a:t>
             </a:fld>
             <a:endParaRPr lang="en-SG"/>
           </a:p>
@@ -3121,7 +3127,7 @@
           <a:p>
             <a:fld id="{48E88D6B-047D-48A7-91CC-F0B0060D7484}" type="datetimeFigureOut">
               <a:rPr lang="en-SG" smtClean="0"/>
-              <a:t>19/3/2026</a:t>
+              <a:t>22/3/2026</a:t>
             </a:fld>
             <a:endParaRPr lang="en-SG"/>
           </a:p>
@@ -3364,7 +3370,7 @@
           <a:p>
             <a:fld id="{48E88D6B-047D-48A7-91CC-F0B0060D7484}" type="datetimeFigureOut">
               <a:rPr lang="en-SG" smtClean="0"/>
-              <a:t>19/3/2026</a:t>
+              <a:t>22/3/2026</a:t>
             </a:fld>
             <a:endParaRPr lang="en-SG"/>
           </a:p>
@@ -5714,6 +5720,492 @@
     <p:extLst>
       <p:ext uri="{BB962C8B-B14F-4D97-AF65-F5344CB8AC3E}">
         <p14:creationId xmlns:p14="http://schemas.microsoft.com/office/powerpoint/2010/main" val="2682366580"/>
+      </p:ext>
+    </p:extLst>
+  </p:cSld>
+  <p:clrMapOvr>
+    <a:masterClrMapping/>
+  </p:clrMapOvr>
+</p:sld>
+</file>
+
+<file path=ppt/slides/slide4.xml><?xml version="1.0" encoding="utf-8"?>
+<p:sld xmlns:a="http://schemas.openxmlformats.org/drawingml/2006/main" xmlns:r="http://schemas.openxmlformats.org/officeDocument/2006/relationships" xmlns:p="http://schemas.openxmlformats.org/presentationml/2006/main">
+  <p:cSld>
+    <p:spTree>
+      <p:nvGrpSpPr>
+        <p:cNvPr id="1" name=""/>
+        <p:cNvGrpSpPr/>
+        <p:nvPr/>
+      </p:nvGrpSpPr>
+      <p:grpSpPr>
+        <a:xfrm>
+          <a:off x="0" y="0"/>
+          <a:ext cx="0" cy="0"/>
+          <a:chOff x="0" y="0"/>
+          <a:chExt cx="0" cy="0"/>
+        </a:xfrm>
+      </p:grpSpPr>
+      <p:sp>
+        <p:nvSpPr>
+          <p:cNvPr id="29" name="Rectangle 28">
+            <a:extLst>
+              <a:ext uri="{FF2B5EF4-FFF2-40B4-BE49-F238E27FC236}">
+                <a16:creationId xmlns:a16="http://schemas.microsoft.com/office/drawing/2014/main" id="{62A460DD-75F7-D012-BEC9-E1F8AA13A805}"/>
+              </a:ext>
+            </a:extLst>
+          </p:cNvPr>
+          <p:cNvSpPr/>
+          <p:nvPr/>
+        </p:nvSpPr>
+        <p:spPr>
+          <a:xfrm>
+            <a:off x="521208" y="219456"/>
+            <a:ext cx="11021567" cy="6355080"/>
+          </a:xfrm>
+          <a:prstGeom prst="rect">
+            <a:avLst/>
+          </a:prstGeom>
+          <a:noFill/>
+        </p:spPr>
+        <p:style>
+          <a:lnRef idx="2">
+            <a:schemeClr val="accent1">
+              <a:shade val="15000"/>
+            </a:schemeClr>
+          </a:lnRef>
+          <a:fillRef idx="1">
+            <a:schemeClr val="accent1"/>
+          </a:fillRef>
+          <a:effectRef idx="0">
+            <a:schemeClr val="accent1"/>
+          </a:effectRef>
+          <a:fontRef idx="minor">
+            <a:schemeClr val="lt1"/>
+          </a:fontRef>
+        </p:style>
+        <p:txBody>
+          <a:bodyPr rtlCol="0" anchor="ctr"/>
+          <a:lstStyle/>
+          <a:p>
+            <a:pPr algn="ctr"/>
+            <a:endParaRPr lang="en-SG" dirty="0"/>
+          </a:p>
+        </p:txBody>
+      </p:sp>
+      <p:pic>
+        <p:nvPicPr>
+          <p:cNvPr id="10" name="Picture 9">
+            <a:extLst>
+              <a:ext uri="{FF2B5EF4-FFF2-40B4-BE49-F238E27FC236}">
+                <a16:creationId xmlns:a16="http://schemas.microsoft.com/office/drawing/2014/main" id="{AFF4A085-6144-61B0-BE97-607101A26CBC}"/>
+              </a:ext>
+            </a:extLst>
+          </p:cNvPr>
+          <p:cNvPicPr>
+            <a:picLocks noChangeAspect="1"/>
+          </p:cNvPicPr>
+          <p:nvPr/>
+        </p:nvPicPr>
+        <p:blipFill>
+          <a:blip r:embed="rId2">
+            <a:extLst>
+              <a:ext uri="{28A0092B-C50C-407E-A947-70E740481C1C}">
+                <a14:useLocalDpi xmlns:a14="http://schemas.microsoft.com/office/drawing/2010/main" val="0"/>
+              </a:ext>
+            </a:extLst>
+          </a:blip>
+          <a:stretch>
+            <a:fillRect/>
+          </a:stretch>
+        </p:blipFill>
+        <p:spPr>
+          <a:xfrm>
+            <a:off x="5744713" y="3303103"/>
+            <a:ext cx="5681082" cy="3096189"/>
+          </a:xfrm>
+          <a:prstGeom prst="rect">
+            <a:avLst/>
+          </a:prstGeom>
+        </p:spPr>
+      </p:pic>
+      <p:pic>
+        <p:nvPicPr>
+          <p:cNvPr id="5" name="Picture 4">
+            <a:extLst>
+              <a:ext uri="{FF2B5EF4-FFF2-40B4-BE49-F238E27FC236}">
+                <a16:creationId xmlns:a16="http://schemas.microsoft.com/office/drawing/2014/main" id="{9E600AB6-0B19-04B5-2211-70CC2162FC8D}"/>
+              </a:ext>
+            </a:extLst>
+          </p:cNvPr>
+          <p:cNvPicPr>
+            <a:picLocks noChangeAspect="1"/>
+          </p:cNvPicPr>
+          <p:nvPr/>
+        </p:nvPicPr>
+        <p:blipFill>
+          <a:blip r:embed="rId3">
+            <a:alphaModFix amt="70000"/>
+            <a:extLst>
+              <a:ext uri="{28A0092B-C50C-407E-A947-70E740481C1C}">
+                <a14:useLocalDpi xmlns:a14="http://schemas.microsoft.com/office/drawing/2010/main" val="0"/>
+              </a:ext>
+            </a:extLst>
+          </a:blip>
+          <a:stretch>
+            <a:fillRect/>
+          </a:stretch>
+        </p:blipFill>
+        <p:spPr>
+          <a:xfrm>
+            <a:off x="766205" y="925468"/>
+            <a:ext cx="5460859" cy="3003473"/>
+          </a:xfrm>
+          <a:prstGeom prst="rect">
+            <a:avLst/>
+          </a:prstGeom>
+        </p:spPr>
+      </p:pic>
+      <p:sp>
+        <p:nvSpPr>
+          <p:cNvPr id="6" name="Rectangle 5">
+            <a:extLst>
+              <a:ext uri="{FF2B5EF4-FFF2-40B4-BE49-F238E27FC236}">
+                <a16:creationId xmlns:a16="http://schemas.microsoft.com/office/drawing/2014/main" id="{A1B71929-A36C-04F0-1D6E-41012C50B2F3}"/>
+              </a:ext>
+            </a:extLst>
+          </p:cNvPr>
+          <p:cNvSpPr/>
+          <p:nvPr/>
+        </p:nvSpPr>
+        <p:spPr>
+          <a:xfrm>
+            <a:off x="649225" y="1490472"/>
+            <a:ext cx="832104" cy="742589"/>
+          </a:xfrm>
+          <a:prstGeom prst="rect">
+            <a:avLst/>
+          </a:prstGeom>
+          <a:noFill/>
+          <a:ln>
+            <a:solidFill>
+              <a:srgbClr val="FF0000"/>
+            </a:solidFill>
+          </a:ln>
+        </p:spPr>
+        <p:style>
+          <a:lnRef idx="2">
+            <a:schemeClr val="accent1">
+              <a:shade val="15000"/>
+            </a:schemeClr>
+          </a:lnRef>
+          <a:fillRef idx="1">
+            <a:schemeClr val="accent1"/>
+          </a:fillRef>
+          <a:effectRef idx="0">
+            <a:schemeClr val="accent1"/>
+          </a:effectRef>
+          <a:fontRef idx="minor">
+            <a:schemeClr val="lt1"/>
+          </a:fontRef>
+        </p:style>
+        <p:txBody>
+          <a:bodyPr rtlCol="0" anchor="ctr"/>
+          <a:lstStyle/>
+          <a:p>
+            <a:pPr algn="ctr"/>
+            <a:endParaRPr lang="en-SG" dirty="0"/>
+          </a:p>
+        </p:txBody>
+      </p:sp>
+      <p:pic>
+        <p:nvPicPr>
+          <p:cNvPr id="8" name="Picture 7">
+            <a:extLst>
+              <a:ext uri="{FF2B5EF4-FFF2-40B4-BE49-F238E27FC236}">
+                <a16:creationId xmlns:a16="http://schemas.microsoft.com/office/drawing/2014/main" id="{57E6A414-7931-C329-6645-E19962B267FC}"/>
+              </a:ext>
+            </a:extLst>
+          </p:cNvPr>
+          <p:cNvPicPr>
+            <a:picLocks noChangeAspect="1"/>
+          </p:cNvPicPr>
+          <p:nvPr/>
+        </p:nvPicPr>
+        <p:blipFill>
+          <a:blip r:embed="rId4">
+            <a:extLst>
+              <a:ext uri="{28A0092B-C50C-407E-A947-70E740481C1C}">
+                <a14:useLocalDpi xmlns:a14="http://schemas.microsoft.com/office/drawing/2010/main" val="0"/>
+              </a:ext>
+            </a:extLst>
+          </a:blip>
+          <a:stretch>
+            <a:fillRect/>
+          </a:stretch>
+        </p:blipFill>
+        <p:spPr>
+          <a:xfrm>
+            <a:off x="6447566" y="866994"/>
+            <a:ext cx="5008821" cy="2414251"/>
+          </a:xfrm>
+          <a:prstGeom prst="rect">
+            <a:avLst/>
+          </a:prstGeom>
+        </p:spPr>
+      </p:pic>
+      <p:sp>
+        <p:nvSpPr>
+          <p:cNvPr id="22" name="Arrow: Down 21">
+            <a:extLst>
+              <a:ext uri="{FF2B5EF4-FFF2-40B4-BE49-F238E27FC236}">
+                <a16:creationId xmlns:a16="http://schemas.microsoft.com/office/drawing/2014/main" id="{794B11D8-71E6-926E-3BA3-EDFBCF61BAFF}"/>
+              </a:ext>
+            </a:extLst>
+          </p:cNvPr>
+          <p:cNvSpPr/>
+          <p:nvPr/>
+        </p:nvSpPr>
+        <p:spPr>
+          <a:xfrm>
+            <a:off x="7038274" y="3152227"/>
+            <a:ext cx="291196" cy="301752"/>
+          </a:xfrm>
+          <a:prstGeom prst="downArrow">
+            <a:avLst/>
+          </a:prstGeom>
+          <a:solidFill>
+            <a:schemeClr val="accent2">
+              <a:lumMod val="75000"/>
+            </a:schemeClr>
+          </a:solidFill>
+        </p:spPr>
+        <p:style>
+          <a:lnRef idx="2">
+            <a:schemeClr val="accent1">
+              <a:shade val="15000"/>
+            </a:schemeClr>
+          </a:lnRef>
+          <a:fillRef idx="1">
+            <a:schemeClr val="accent1"/>
+          </a:fillRef>
+          <a:effectRef idx="0">
+            <a:schemeClr val="accent1"/>
+          </a:effectRef>
+          <a:fontRef idx="minor">
+            <a:schemeClr val="lt1"/>
+          </a:fontRef>
+        </p:style>
+        <p:txBody>
+          <a:bodyPr rtlCol="0" anchor="ctr"/>
+          <a:lstStyle/>
+          <a:p>
+            <a:pPr algn="ctr"/>
+            <a:endParaRPr lang="en-SG"/>
+          </a:p>
+        </p:txBody>
+      </p:sp>
+      <p:sp>
+        <p:nvSpPr>
+          <p:cNvPr id="23" name="Arrow: Right 22">
+            <a:extLst>
+              <a:ext uri="{FF2B5EF4-FFF2-40B4-BE49-F238E27FC236}">
+                <a16:creationId xmlns:a16="http://schemas.microsoft.com/office/drawing/2014/main" id="{0F496D45-02D0-FABA-E5AC-0832CD30B09B}"/>
+              </a:ext>
+            </a:extLst>
+          </p:cNvPr>
+          <p:cNvSpPr/>
+          <p:nvPr/>
+        </p:nvSpPr>
+        <p:spPr>
+          <a:xfrm>
+            <a:off x="1481329" y="1490472"/>
+            <a:ext cx="4935645" cy="146304"/>
+          </a:xfrm>
+          <a:prstGeom prst="rightArrow">
+            <a:avLst/>
+          </a:prstGeom>
+          <a:solidFill>
+            <a:schemeClr val="accent2">
+              <a:lumMod val="75000"/>
+            </a:schemeClr>
+          </a:solidFill>
+        </p:spPr>
+        <p:style>
+          <a:lnRef idx="2">
+            <a:schemeClr val="accent1">
+              <a:shade val="15000"/>
+            </a:schemeClr>
+          </a:lnRef>
+          <a:fillRef idx="1">
+            <a:schemeClr val="accent1"/>
+          </a:fillRef>
+          <a:effectRef idx="0">
+            <a:schemeClr val="accent1"/>
+          </a:effectRef>
+          <a:fontRef idx="minor">
+            <a:schemeClr val="lt1"/>
+          </a:fontRef>
+        </p:style>
+        <p:txBody>
+          <a:bodyPr rtlCol="0" anchor="ctr"/>
+          <a:lstStyle/>
+          <a:p>
+            <a:pPr algn="ctr"/>
+            <a:endParaRPr lang="en-SG"/>
+          </a:p>
+        </p:txBody>
+      </p:sp>
+      <p:sp>
+        <p:nvSpPr>
+          <p:cNvPr id="25" name="Arrow: Down 24">
+            <a:extLst>
+              <a:ext uri="{FF2B5EF4-FFF2-40B4-BE49-F238E27FC236}">
+                <a16:creationId xmlns:a16="http://schemas.microsoft.com/office/drawing/2014/main" id="{C03F4B34-88B6-5D9C-204A-FD20E57B0800}"/>
+              </a:ext>
+            </a:extLst>
+          </p:cNvPr>
+          <p:cNvSpPr/>
+          <p:nvPr/>
+        </p:nvSpPr>
+        <p:spPr>
+          <a:xfrm>
+            <a:off x="956115" y="2339901"/>
+            <a:ext cx="141797" cy="1624653"/>
+          </a:xfrm>
+          <a:prstGeom prst="downArrow">
+            <a:avLst/>
+          </a:prstGeom>
+          <a:solidFill>
+            <a:schemeClr val="accent2">
+              <a:lumMod val="75000"/>
+            </a:schemeClr>
+          </a:solidFill>
+        </p:spPr>
+        <p:style>
+          <a:lnRef idx="2">
+            <a:schemeClr val="accent1">
+              <a:shade val="15000"/>
+            </a:schemeClr>
+          </a:lnRef>
+          <a:fillRef idx="1">
+            <a:schemeClr val="accent1"/>
+          </a:fillRef>
+          <a:effectRef idx="0">
+            <a:schemeClr val="accent1"/>
+          </a:effectRef>
+          <a:fontRef idx="minor">
+            <a:schemeClr val="lt1"/>
+          </a:fontRef>
+        </p:style>
+        <p:txBody>
+          <a:bodyPr rtlCol="0" anchor="ctr"/>
+          <a:lstStyle/>
+          <a:p>
+            <a:pPr algn="ctr"/>
+            <a:endParaRPr lang="en-SG"/>
+          </a:p>
+        </p:txBody>
+      </p:sp>
+      <p:pic>
+        <p:nvPicPr>
+          <p:cNvPr id="27" name="Picture 26">
+            <a:extLst>
+              <a:ext uri="{FF2B5EF4-FFF2-40B4-BE49-F238E27FC236}">
+                <a16:creationId xmlns:a16="http://schemas.microsoft.com/office/drawing/2014/main" id="{987A13A8-9DF4-872D-D450-157D20B2752D}"/>
+              </a:ext>
+            </a:extLst>
+          </p:cNvPr>
+          <p:cNvPicPr>
+            <a:picLocks noChangeAspect="1"/>
+          </p:cNvPicPr>
+          <p:nvPr/>
+        </p:nvPicPr>
+        <p:blipFill>
+          <a:blip r:embed="rId5">
+            <a:extLst>
+              <a:ext uri="{28A0092B-C50C-407E-A947-70E740481C1C}">
+                <a14:useLocalDpi xmlns:a14="http://schemas.microsoft.com/office/drawing/2010/main" val="0"/>
+              </a:ext>
+            </a:extLst>
+          </a:blip>
+          <a:stretch>
+            <a:fillRect/>
+          </a:stretch>
+        </p:blipFill>
+        <p:spPr>
+          <a:xfrm>
+            <a:off x="882963" y="4071394"/>
+            <a:ext cx="4250276" cy="2265397"/>
+          </a:xfrm>
+          <a:prstGeom prst="rect">
+            <a:avLst/>
+          </a:prstGeom>
+          <a:ln w="9525">
+            <a:solidFill>
+              <a:schemeClr val="tx1"/>
+            </a:solidFill>
+          </a:ln>
+        </p:spPr>
+      </p:pic>
+      <p:sp>
+        <p:nvSpPr>
+          <p:cNvPr id="28" name="TextBox 27">
+            <a:extLst>
+              <a:ext uri="{FF2B5EF4-FFF2-40B4-BE49-F238E27FC236}">
+                <a16:creationId xmlns:a16="http://schemas.microsoft.com/office/drawing/2014/main" id="{7134F83E-33E2-EE27-78B3-588D26ECC2DC}"/>
+              </a:ext>
+            </a:extLst>
+          </p:cNvPr>
+          <p:cNvSpPr txBox="1"/>
+          <p:nvPr/>
+        </p:nvSpPr>
+        <p:spPr>
+          <a:xfrm>
+            <a:off x="649225" y="412134"/>
+            <a:ext cx="10776570" cy="461665"/>
+          </a:xfrm>
+          <a:prstGeom prst="rect">
+            <a:avLst/>
+          </a:prstGeom>
+          <a:solidFill>
+            <a:schemeClr val="accent2">
+              <a:lumMod val="75000"/>
+            </a:schemeClr>
+          </a:solidFill>
+          <a:ln w="19050">
+            <a:solidFill>
+              <a:schemeClr val="tx1"/>
+            </a:solidFill>
+            <a:prstDash val="sysDash"/>
+          </a:ln>
+        </p:spPr>
+        <p:txBody>
+          <a:bodyPr wrap="square" rtlCol="0">
+            <a:spAutoFit/>
+          </a:bodyPr>
+          <a:lstStyle/>
+          <a:p>
+            <a:r>
+              <a:rPr lang="en-US" sz="2400" b="1" dirty="0">
+                <a:solidFill>
+                  <a:schemeClr val="bg1"/>
+                </a:solidFill>
+              </a:rPr>
+              <a:t>Fast Way to Setup an ERP(IT) System For the Critical Infra Cyber Range</a:t>
+            </a:r>
+            <a:endParaRPr lang="en-SG" sz="2400" b="1" dirty="0">
+              <a:solidFill>
+                <a:schemeClr val="bg1"/>
+              </a:solidFill>
+            </a:endParaRPr>
+          </a:p>
+        </p:txBody>
+      </p:sp>
+    </p:spTree>
+    <p:extLst>
+      <p:ext uri="{BB962C8B-B14F-4D97-AF65-F5344CB8AC3E}">
+        <p14:creationId xmlns:p14="http://schemas.microsoft.com/office/powerpoint/2010/main" val="1360242953"/>
       </p:ext>
     </p:extLst>
   </p:cSld>

</xml_diff>